<commit_message>
Added .env and changes for that
</commit_message>
<xml_diff>
--- a/voice-assistant-ppt-25.pptx
+++ b/voice-assistant-ppt-25.pptx
@@ -227,7 +227,7 @@
           <a:p>
             <a:fld id="{EF192FCB-BB56-4C63-9BD6-D86A31EC9420}" type="datetimeFigureOut">
               <a:rPr lang="en-IN" smtClean="0"/>
-              <a:t>24-04-2025</a:t>
+              <a:t>29-04-2025</a:t>
             </a:fld>
             <a:endParaRPr lang="en-IN"/>
           </a:p>
@@ -570,6 +570,90 @@
     <p:extLst>
       <p:ext uri="{BB962C8B-B14F-4D97-AF65-F5344CB8AC3E}">
         <p14:creationId xmlns:p14="http://schemas.microsoft.com/office/powerpoint/2010/main" val="2080395032"/>
+      </p:ext>
+    </p:extLst>
+  </p:cSld>
+  <p:clrMapOvr>
+    <a:masterClrMapping/>
+  </p:clrMapOvr>
+</p:notes>
+</file>
+
+<file path=ppt/notesSlides/notesSlide2.xml><?xml version="1.0" encoding="utf-8"?>
+<p:notes xmlns:a="http://schemas.openxmlformats.org/drawingml/2006/main" xmlns:r="http://schemas.openxmlformats.org/officeDocument/2006/relationships" xmlns:p="http://schemas.openxmlformats.org/presentationml/2006/main">
+  <p:cSld>
+    <p:spTree>
+      <p:nvGrpSpPr>
+        <p:cNvPr id="1" name=""/>
+        <p:cNvGrpSpPr/>
+        <p:nvPr/>
+      </p:nvGrpSpPr>
+      <p:grpSpPr>
+        <a:xfrm>
+          <a:off x="0" y="0"/>
+          <a:ext cx="0" cy="0"/>
+          <a:chOff x="0" y="0"/>
+          <a:chExt cx="0" cy="0"/>
+        </a:xfrm>
+      </p:grpSpPr>
+      <p:sp>
+        <p:nvSpPr>
+          <p:cNvPr id="2" name="Slide Image Placeholder 1"/>
+          <p:cNvSpPr>
+            <a:spLocks noGrp="1" noRot="1" noChangeAspect="1"/>
+          </p:cNvSpPr>
+          <p:nvPr>
+            <p:ph type="sldImg"/>
+          </p:nvPr>
+        </p:nvSpPr>
+        <p:spPr/>
+      </p:sp>
+      <p:sp>
+        <p:nvSpPr>
+          <p:cNvPr id="3" name="Notes Placeholder 2"/>
+          <p:cNvSpPr>
+            <a:spLocks noGrp="1"/>
+          </p:cNvSpPr>
+          <p:nvPr>
+            <p:ph type="body" idx="1"/>
+          </p:nvPr>
+        </p:nvSpPr>
+        <p:spPr/>
+        <p:txBody>
+          <a:bodyPr/>
+          <a:lstStyle/>
+          <a:p>
+            <a:endParaRPr lang="en-IN" dirty="0"/>
+          </a:p>
+        </p:txBody>
+      </p:sp>
+      <p:sp>
+        <p:nvSpPr>
+          <p:cNvPr id="4" name="Slide Number Placeholder 3"/>
+          <p:cNvSpPr>
+            <a:spLocks noGrp="1"/>
+          </p:cNvSpPr>
+          <p:nvPr>
+            <p:ph type="sldNum" sz="quarter" idx="5"/>
+          </p:nvPr>
+        </p:nvSpPr>
+        <p:spPr/>
+        <p:txBody>
+          <a:bodyPr/>
+          <a:lstStyle/>
+          <a:p>
+            <a:fld id="{1D4C9F64-E0B2-472D-A4AF-AF1218808758}" type="slidenum">
+              <a:rPr lang="en-IN" smtClean="0"/>
+              <a:t>14</a:t>
+            </a:fld>
+            <a:endParaRPr lang="en-IN"/>
+          </a:p>
+        </p:txBody>
+      </p:sp>
+    </p:spTree>
+    <p:extLst>
+      <p:ext uri="{BB962C8B-B14F-4D97-AF65-F5344CB8AC3E}">
+        <p14:creationId xmlns:p14="http://schemas.microsoft.com/office/powerpoint/2010/main" val="409481155"/>
       </p:ext>
     </p:extLst>
   </p:cSld>
@@ -2292,7 +2376,7 @@
           <p:nvPr>
             <p:extLst>
               <p:ext uri="{D42A27DB-BD31-4B8C-83A1-F6EECF244321}">
-                <p14:modId xmlns:p14="http://schemas.microsoft.com/office/powerpoint/2010/main" val="275162505"/>
+                <p14:modId xmlns:p14="http://schemas.microsoft.com/office/powerpoint/2010/main" val="3536396908"/>
               </p:ext>
             </p:extLst>
           </p:nvPr>
@@ -2429,7 +2513,7 @@
                       <a:pPr algn="ctr"/>
                       <a:r>
                         <a:rPr lang="en-US" dirty="0"/>
-                        <a:t>S1901004229</a:t>
+                        <a:t>S400100687</a:t>
                       </a:r>
                     </a:p>
                   </a:txBody>
@@ -2492,7 +2576,7 @@
                       <a:pPr algn="ctr"/>
                       <a:r>
                         <a:rPr lang="en-US" dirty="0"/>
-                        <a:t>S1901004391</a:t>
+                        <a:t>S400100829</a:t>
                       </a:r>
                     </a:p>
                   </a:txBody>
@@ -2551,7 +2635,7 @@
                       <a:pPr algn="ctr"/>
                       <a:r>
                         <a:rPr lang="en-US" dirty="0"/>
-                        <a:t>S1901004204</a:t>
+                        <a:t>S400100666</a:t>
                       </a:r>
                     </a:p>
                   </a:txBody>
@@ -2606,7 +2690,7 @@
                       <a:pPr algn="ctr"/>
                       <a:r>
                         <a:rPr lang="en-US" dirty="0"/>
-                        <a:t>S1901004201</a:t>
+                        <a:t>S400100663</a:t>
                       </a:r>
                     </a:p>
                   </a:txBody>
@@ -4255,8 +4339,20 @@
                 <a:latin typeface="Times New Roman" panose="02020603050405020304" pitchFamily="18" charset="0"/>
                 <a:cs typeface="Times New Roman" panose="02020603050405020304" pitchFamily="18" charset="0"/>
               </a:rPr>
-              <a:t>ChatGPT</a:t>
-            </a:r>
+              <a:t>IEEE Research Paper - </a:t>
+            </a:r>
+            <a:r>
+              <a:rPr lang="en-US" sz="2400" dirty="0">
+                <a:latin typeface="Times New Roman" panose="02020603050405020304" pitchFamily="18" charset="0"/>
+                <a:cs typeface="Times New Roman" panose="02020603050405020304" pitchFamily="18" charset="0"/>
+                <a:hlinkClick r:id="rId3"/>
+              </a:rPr>
+              <a:t>https://ieeexplore.ieee.org/document/9210344</a:t>
+            </a:r>
+            <a:endParaRPr lang="en-US" sz="2400" dirty="0">
+              <a:latin typeface="Times New Roman" panose="02020603050405020304" pitchFamily="18" charset="0"/>
+              <a:cs typeface="Times New Roman" panose="02020603050405020304" pitchFamily="18" charset="0"/>
+            </a:endParaRPr>
           </a:p>
           <a:p>
             <a:endParaRPr lang="en-US" sz="2400" dirty="0">

</xml_diff>